<commit_message>
Refactor: remove challenge identification prefixes and add PPT slide disclaimers
</commit_message>
<xml_diff>
--- a/AI_Wealth_Copilot_Pitch_Deck.pptx
+++ b/AI_Wealth_Copilot_Pitch_Deck.pptx
@@ -3137,7 +3137,7 @@
               </a:defRPr>
             </a:pPr>
             <a:r>
-              <a:t>AI WEALTH COPILOT</a:t>
+              <a:t>AI WEALTH COPILOT PROTOTYPE</a:t>
             </a:r>
           </a:p>
           <a:p>
@@ -3210,7 +3210,7 @@
             </a:r>
             <a:br/>
             <a:r>
-              <a:t>• Problem Statement: Problem Statement 1 – Digital Wealth Management</a:t>
+              <a:t>• Problem Statement: Digital Wealth Management</a:t>
             </a:r>
             <a:br/>
             <a:r>
@@ -3344,6 +3344,42 @@
             <a:br/>
             <a:r>
               <a:t>Rigid rule engines frustrate customers, while black-box generative AI tools hallucinate recommendations. A hybrid model resolves this tension by using AI for natural intent capture and audit rationales, with a rules-first compliance engine checking every checkout.</a:t>
+            </a:r>
+          </a:p>
+        </p:txBody>
+      </p:sp>
+      <p:sp>
+        <p:nvSpPr>
+          <p:cNvPr id="6" name="TextBox 5"/>
+          <p:cNvSpPr txBox="1"/>
+          <p:nvPr/>
+        </p:nvSpPr>
+        <p:spPr>
+          <a:xfrm>
+            <a:off x="731520" y="6217920"/>
+            <a:ext cx="10698480" cy="365760"/>
+          </a:xfrm>
+          <a:prstGeom prst="rect">
+            <a:avLst/>
+          </a:prstGeom>
+          <a:noFill/>
+        </p:spPr>
+        <p:txBody>
+          <a:bodyPr wrap="square">
+            <a:spAutoFit/>
+          </a:bodyPr>
+          <a:lstStyle/>
+          <a:p>
+            <a:pPr>
+              <a:defRPr sz="1000" i="1">
+                <a:solidFill>
+                  <a:srgbClr val="DEE2E6"/>
+                </a:solidFill>
+                <a:latin typeface="Arial"/>
+              </a:defRPr>
+            </a:pPr>
+            <a:r>
+              <a:t>This is an independent prototype created for demonstration purposes. It is not affiliated with or endorsed by any bank.</a:t>
             </a:r>
           </a:p>
         </p:txBody>
@@ -3450,7 +3486,7 @@
               </a:defRPr>
             </a:pPr>
             <a:r>
-              <a:t>AI WEALTH COPILOT</a:t>
+              <a:t>AI WEALTH COPILOT PROTOTYPE</a:t>
             </a:r>
           </a:p>
         </p:txBody>
@@ -4300,6 +4336,42 @@
           </a:p>
         </p:txBody>
       </p:sp>
+      <p:sp>
+        <p:nvSpPr>
+          <p:cNvPr id="9" name="TextBox 8"/>
+          <p:cNvSpPr txBox="1"/>
+          <p:nvPr/>
+        </p:nvSpPr>
+        <p:spPr>
+          <a:xfrm>
+            <a:off x="731520" y="6217920"/>
+            <a:ext cx="10698480" cy="365760"/>
+          </a:xfrm>
+          <a:prstGeom prst="rect">
+            <a:avLst/>
+          </a:prstGeom>
+          <a:noFill/>
+        </p:spPr>
+        <p:txBody>
+          <a:bodyPr wrap="square">
+            <a:spAutoFit/>
+          </a:bodyPr>
+          <a:lstStyle/>
+          <a:p>
+            <a:pPr>
+              <a:defRPr sz="1000" i="1">
+                <a:solidFill>
+                  <a:srgbClr val="DEE2E6"/>
+                </a:solidFill>
+                <a:latin typeface="Arial"/>
+              </a:defRPr>
+            </a:pPr>
+            <a:r>
+              <a:t>This is an independent prototype created for demonstration purposes. It is not affiliated with or endorsed by any bank.</a:t>
+            </a:r>
+          </a:p>
+        </p:txBody>
+      </p:sp>
     </p:spTree>
   </p:cSld>
   <p:clrMapOvr>
@@ -4402,7 +4474,7 @@
               </a:defRPr>
             </a:pPr>
             <a:r>
-              <a:t>AI WEALTH COPILOT</a:t>
+              <a:t>AI WEALTH COPILOT PROTOTYPE</a:t>
             </a:r>
           </a:p>
         </p:txBody>
@@ -4521,7 +4593,7 @@
               </a:defRPr>
             </a:pPr>
             <a:r>
-              <a:t>AI WEALTH COPILOT CORE PILOT</a:t>
+              <a:t>AI WEALTH COPILOT PROTOTYPE</a:t>
             </a:r>
           </a:p>
           <a:p>
@@ -4835,7 +4907,7 @@
               </a:defRPr>
             </a:pPr>
             <a:r>
-              <a:t>AI WEALTH COPILOT</a:t>
+              <a:t>AI WEALTH COPILOT PROTOTYPE</a:t>
             </a:r>
           </a:p>
         </p:txBody>
@@ -5368,7 +5440,7 @@
               </a:defRPr>
             </a:pPr>
             <a:r>
-              <a:t>AI WEALTH COPILOT</a:t>
+              <a:t>AI WEALTH COPILOT PROTOTYPE</a:t>
             </a:r>
           </a:p>
         </p:txBody>
@@ -6271,7 +6343,7 @@
               </a:defRPr>
             </a:pPr>
             <a:r>
-              <a:t>AI WEALTH COPILOT</a:t>
+              <a:t>AI WEALTH COPILOT PROTOTYPE</a:t>
             </a:r>
           </a:p>
         </p:txBody>
@@ -7194,7 +7266,7 @@
               </a:defRPr>
             </a:pPr>
             <a:r>
-              <a:t>AI WEALTH COPILOT</a:t>
+              <a:t>AI WEALTH COPILOT PROTOTYPE</a:t>
             </a:r>
           </a:p>
         </p:txBody>
@@ -7796,7 +7868,7 @@
               </a:defRPr>
             </a:pPr>
             <a:r>
-              <a:t>AI WEALTH COPILOT</a:t>
+              <a:t>AI WEALTH COPILOT PROTOTYPE</a:t>
             </a:r>
           </a:p>
         </p:txBody>
@@ -8440,7 +8512,7 @@
               </a:defRPr>
             </a:pPr>
             <a:r>
-              <a:t>AI WEALTH COPILOT</a:t>
+              <a:t>AI WEALTH COPILOT PROTOTYPE</a:t>
             </a:r>
           </a:p>
         </p:txBody>
@@ -9023,7 +9095,7 @@
               </a:defRPr>
             </a:pPr>
             <a:r>
-              <a:t>AI WEALTH COPILOT</a:t>
+              <a:t>AI WEALTH COPILOT PROTOTYPE</a:t>
             </a:r>
           </a:p>
         </p:txBody>

</xml_diff>